<commit_message>
Fix research-problem hierarchy in defense slides.
Separate the Cap.1 central NISQ advantage question from the two
original questions that follow empirical alignment findings; use
exact wording from investigacion_original.tex for P1/P2.

Co-authored-by: Juan David Prada Malagon  <pradamalagonjd@gmail.com>
</commit_message>
<xml_diff>
--- a/Entregas/Defensa/Defensa_TFM_QuantumAdvantage.pptx
+++ b/Entregas/Defensa/Defensa_TFM_QuantumAdvantage.pptx
@@ -3957,7 +3957,7 @@
                 </a:solidFill>
                 <a:latin typeface="Calibri"/>
               </a:rPr>
-              <a:t>PROBLEMAS DE INVESTIGACIÓN</a:t>
+              <a:t>PREGUNTAS ORIGINALES</a:t>
             </a:r>
           </a:p>
         </p:txBody>
@@ -3996,7 +3996,7 @@
                 </a:solidFill>
                 <a:latin typeface="Calibri"/>
               </a:rPr>
-              <a:t>Contribución original</a:t>
+              <a:t>Surgen tras la evidencia de ventaja condicionada</a:t>
             </a:r>
           </a:p>
         </p:txBody>
@@ -4046,14 +4046,69 @@
       </p:sp>
       <p:sp>
         <p:nvSpPr>
-          <p:cNvPr id="6" name="Rectangle 5"/>
+          <p:cNvPr id="6" name="TextBox 5"/>
+          <p:cNvSpPr txBox="1"/>
+          <p:nvPr/>
+        </p:nvSpPr>
+        <p:spPr>
+          <a:xfrm>
+            <a:off x="502920" y="1170432"/>
+            <a:ext cx="11155680" cy="457200"/>
+          </a:xfrm>
+          <a:prstGeom prst="rect">
+            <a:avLst/>
+          </a:prstGeom>
+          <a:noFill/>
+        </p:spPr>
+        <p:txBody>
+          <a:bodyPr wrap="square">
+            <a:spAutoFit/>
+          </a:bodyPr>
+          <a:lstStyle/>
+          <a:p>
+            <a:pPr algn="l">
+              <a:spcAft>
+                <a:spcPts val="300"/>
+              </a:spcAft>
+            </a:pPr>
+            <a:r>
+              <a:rPr sz="1200" b="0">
+                <a:solidFill>
+                  <a:srgbClr val="6B737A"/>
+                </a:solidFill>
+                <a:latin typeface="Calibri"/>
+              </a:rPr>
+              <a:t>Hallazgo previo: la ventaja en kernels aparece con alineación mapa↔generador y desaparece sin ella.</a:t>
+            </a:r>
+          </a:p>
+          <a:p>
+            <a:pPr algn="l">
+              <a:spcAft>
+                <a:spcPts val="300"/>
+              </a:spcAft>
+            </a:pPr>
+            <a:r>
+              <a:rPr sz="1200" b="0">
+                <a:solidFill>
+                  <a:srgbClr val="6B737A"/>
+                </a:solidFill>
+                <a:latin typeface="Calibri"/>
+              </a:rPr>
+              <a:t>Eso abre dos preguntas nuevas (Cap. investigación original):</a:t>
+            </a:r>
+          </a:p>
+        </p:txBody>
+      </p:sp>
+      <p:sp>
+        <p:nvSpPr>
+          <p:cNvPr id="7" name="Rectangle 6"/>
           <p:cNvSpPr/>
           <p:nvPr/>
         </p:nvSpPr>
         <p:spPr>
           <a:xfrm>
-            <a:off x="502920" y="1325880"/>
-            <a:ext cx="5486400" cy="4846320"/>
+            <a:off x="502920" y="1783080"/>
+            <a:ext cx="11155680" cy="2057400"/>
           </a:xfrm>
           <a:prstGeom prst="rect">
             <a:avLst/>
@@ -4091,14 +4146,14 @@
       </p:sp>
       <p:sp>
         <p:nvSpPr>
-          <p:cNvPr id="7" name="Rectangle 6"/>
+          <p:cNvPr id="8" name="Rectangle 7"/>
           <p:cNvSpPr/>
           <p:nvPr/>
         </p:nvSpPr>
         <p:spPr>
           <a:xfrm>
-            <a:off x="502920" y="1325880"/>
-            <a:ext cx="5486400" cy="640080"/>
+            <a:off x="502920" y="1783080"/>
+            <a:ext cx="73152" cy="2057400"/>
           </a:xfrm>
           <a:prstGeom prst="rect">
             <a:avLst/>
@@ -4134,179 +4189,147 @@
       </p:sp>
       <p:sp>
         <p:nvSpPr>
-          <p:cNvPr id="8" name="TextBox 7"/>
-          <p:cNvSpPr txBox="1"/>
-          <p:nvPr/>
-        </p:nvSpPr>
-        <p:spPr>
-          <a:xfrm>
-            <a:off x="777240" y="1463040"/>
-            <a:ext cx="4937760" cy="411480"/>
-          </a:xfrm>
-          <a:prstGeom prst="rect">
-            <a:avLst/>
-          </a:prstGeom>
-          <a:noFill/>
-        </p:spPr>
-        <p:txBody>
-          <a:bodyPr wrap="square">
-            <a:spAutoFit/>
-          </a:bodyPr>
-          <a:lstStyle/>
-          <a:p>
-            <a:pPr algn="l">
-              <a:spcAft>
-                <a:spcPts val="300"/>
-              </a:spcAft>
-            </a:pPr>
-            <a:r>
-              <a:rPr sz="1600" b="1">
-                <a:solidFill>
-                  <a:srgbClr val="FFFFFF"/>
-                </a:solidFill>
-                <a:latin typeface="Calibri"/>
-              </a:rPr>
-              <a:t>P1 · Tests de cuanticidad</a:t>
-            </a:r>
-          </a:p>
-        </p:txBody>
-      </p:sp>
-      <p:sp>
-        <p:nvSpPr>
           <p:cNvPr id="9" name="TextBox 8"/>
           <p:cNvSpPr txBox="1"/>
           <p:nvPr/>
         </p:nvSpPr>
         <p:spPr>
           <a:xfrm>
-            <a:off x="777240" y="2377440"/>
-            <a:ext cx="4937760" cy="2011680"/>
-          </a:xfrm>
-          <a:prstGeom prst="rect">
-            <a:avLst/>
-          </a:prstGeom>
-          <a:noFill/>
-        </p:spPr>
-        <p:txBody>
-          <a:bodyPr wrap="square">
-            <a:spAutoFit/>
-          </a:bodyPr>
-          <a:lstStyle/>
-          <a:p>
-            <a:pPr algn="l">
-              <a:spcAft>
-                <a:spcPts val="300"/>
-              </a:spcAft>
-            </a:pPr>
-            <a:r>
-              <a:rPr sz="2000" b="1">
+            <a:off x="777240" y="1920240"/>
+            <a:ext cx="10515600" cy="274320"/>
+          </a:xfrm>
+          <a:prstGeom prst="rect">
+            <a:avLst/>
+          </a:prstGeom>
+          <a:noFill/>
+        </p:spPr>
+        <p:txBody>
+          <a:bodyPr wrap="square">
+            <a:spAutoFit/>
+          </a:bodyPr>
+          <a:lstStyle/>
+          <a:p>
+            <a:pPr algn="l">
+              <a:spcAft>
+                <a:spcPts val="300"/>
+              </a:spcAft>
+            </a:pPr>
+            <a:r>
+              <a:rPr sz="1200" b="1">
+                <a:solidFill>
+                  <a:srgbClr val="0B6E6A"/>
+                </a:solidFill>
+                <a:latin typeface="Calibri"/>
+              </a:rPr>
+              <a:t>P1  ·  TESTS DE CUANTICIDAD</a:t>
+            </a:r>
+          </a:p>
+        </p:txBody>
+      </p:sp>
+      <p:sp>
+        <p:nvSpPr>
+          <p:cNvPr id="10" name="TextBox 9"/>
+          <p:cNvSpPr txBox="1"/>
+          <p:nvPr/>
+        </p:nvSpPr>
+        <p:spPr>
+          <a:xfrm>
+            <a:off x="777240" y="2286000"/>
+            <a:ext cx="10515600" cy="914400"/>
+          </a:xfrm>
+          <a:prstGeom prst="rect">
+            <a:avLst/>
+          </a:prstGeom>
+          <a:noFill/>
+        </p:spPr>
+        <p:txBody>
+          <a:bodyPr wrap="square">
+            <a:spAutoFit/>
+          </a:bodyPr>
+          <a:lstStyle/>
+          <a:p>
+            <a:pPr algn="l">
+              <a:spcAft>
+                <a:spcPts val="300"/>
+              </a:spcAft>
+            </a:pPr>
+            <a:r>
+              <a:rPr sz="1500" b="1">
                 <a:solidFill>
                   <a:srgbClr val="14181C"/>
                 </a:solidFill>
                 <a:latin typeface="Calibri"/>
               </a:rPr>
-              <a:t>¿Hay un indicador a priori</a:t>
-            </a:r>
-          </a:p>
-          <a:p>
-            <a:pPr algn="l">
-              <a:spcAft>
-                <a:spcPts val="300"/>
-              </a:spcAft>
-            </a:pPr>
-            <a:r>
-              <a:rPr sz="2000" b="1">
+              <a:t>¿Existe algún indicador calculable a priori sobre un dataset que permita</a:t>
+            </a:r>
+          </a:p>
+          <a:p>
+            <a:pPr algn="l">
+              <a:spcAft>
+                <a:spcPts val="300"/>
+              </a:spcAft>
+            </a:pPr>
+            <a:r>
+              <a:rPr sz="1500" b="1">
                 <a:solidFill>
                   <a:srgbClr val="14181C"/>
                 </a:solidFill>
                 <a:latin typeface="Calibri"/>
               </a:rPr>
-              <a:t>que prediga si un método</a:t>
-            </a:r>
-          </a:p>
-          <a:p>
-            <a:pPr algn="l">
-              <a:spcAft>
-                <a:spcPts val="300"/>
-              </a:spcAft>
-            </a:pPr>
-            <a:r>
-              <a:rPr sz="2000" b="1">
-                <a:solidFill>
-                  <a:srgbClr val="14181C"/>
-                </a:solidFill>
-                <a:latin typeface="Calibri"/>
-              </a:rPr>
-              <a:t>cuántico tendrá ventaja?</a:t>
-            </a:r>
-          </a:p>
-        </p:txBody>
-      </p:sp>
-      <p:sp>
-        <p:nvSpPr>
-          <p:cNvPr id="10" name="TextBox 9"/>
-          <p:cNvSpPr txBox="1"/>
-          <p:nvPr/>
-        </p:nvSpPr>
-        <p:spPr>
-          <a:xfrm>
-            <a:off x="777240" y="4846320"/>
-            <a:ext cx="4937760" cy="914400"/>
-          </a:xfrm>
-          <a:prstGeom prst="rect">
-            <a:avLst/>
-          </a:prstGeom>
-          <a:noFill/>
-        </p:spPr>
-        <p:txBody>
-          <a:bodyPr wrap="square">
-            <a:spAutoFit/>
-          </a:bodyPr>
-          <a:lstStyle/>
-          <a:p>
-            <a:pPr algn="l">
-              <a:spcAft>
-                <a:spcPts val="300"/>
-              </a:spcAft>
-            </a:pPr>
-            <a:r>
-              <a:rPr sz="1400" b="0">
+              <a:t>predecir si un algoritmo cuántico mostrará ventaja sobre los clásicos?</a:t>
+            </a:r>
+          </a:p>
+        </p:txBody>
+      </p:sp>
+      <p:sp>
+        <p:nvSpPr>
+          <p:cNvPr id="11" name="TextBox 10"/>
+          <p:cNvSpPr txBox="1"/>
+          <p:nvPr/>
+        </p:nvSpPr>
+        <p:spPr>
+          <a:xfrm>
+            <a:off x="777240" y="3246120"/>
+            <a:ext cx="10515600" cy="365760"/>
+          </a:xfrm>
+          <a:prstGeom prst="rect">
+            <a:avLst/>
+          </a:prstGeom>
+          <a:noFill/>
+        </p:spPr>
+        <p:txBody>
+          <a:bodyPr wrap="square">
+            <a:spAutoFit/>
+          </a:bodyPr>
+          <a:lstStyle/>
+          <a:p>
+            <a:pPr algn="l">
+              <a:spcAft>
+                <a:spcPts val="300"/>
+              </a:spcAft>
+            </a:pPr>
+            <a:r>
+              <a:rPr sz="1200" b="0">
                 <a:solidFill>
                   <a:srgbClr val="6B737A"/>
                 </a:solidFill>
                 <a:latin typeface="Calibri"/>
               </a:rPr>
-              <a:t>Propuesta: score Q(D)</a:t>
-            </a:r>
-          </a:p>
-          <a:p>
-            <a:pPr algn="l">
-              <a:spcAft>
-                <a:spcPts val="300"/>
-              </a:spcAft>
-            </a:pPr>
-            <a:r>
-              <a:rPr sz="1400" b="0">
-                <a:solidFill>
-                  <a:srgbClr val="6B737A"/>
-                </a:solidFill>
-                <a:latin typeface="Calibri"/>
-              </a:rPr>
-              <a:t>alineación + entropía + d_F</a:t>
-            </a:r>
-          </a:p>
-        </p:txBody>
-      </p:sp>
-      <p:sp>
-        <p:nvSpPr>
-          <p:cNvPr id="11" name="Rectangle 10"/>
+              <a:t>Respuesta propuesta en este TFM: score compuesto Q(D)  (alineación · entropía espectral · d_F)</a:t>
+            </a:r>
+          </a:p>
+        </p:txBody>
+      </p:sp>
+      <p:sp>
+        <p:nvSpPr>
+          <p:cNvPr id="12" name="Rectangle 11"/>
           <p:cNvSpPr/>
           <p:nvPr/>
         </p:nvSpPr>
         <p:spPr>
           <a:xfrm>
-            <a:off x="6217920" y="1325880"/>
-            <a:ext cx="5486400" cy="4846320"/>
+            <a:off x="502920" y="3886200"/>
+            <a:ext cx="11155680" cy="2286000"/>
           </a:xfrm>
           <a:prstGeom prst="rect">
             <a:avLst/>
@@ -4344,14 +4367,14 @@
       </p:sp>
       <p:sp>
         <p:nvSpPr>
-          <p:cNvPr id="12" name="Rectangle 11"/>
+          <p:cNvPr id="13" name="Rectangle 12"/>
           <p:cNvSpPr/>
           <p:nvPr/>
         </p:nvSpPr>
         <p:spPr>
           <a:xfrm>
-            <a:off x="6217920" y="1325880"/>
-            <a:ext cx="5486400" cy="640080"/>
+            <a:off x="502920" y="3886200"/>
+            <a:ext cx="73152" cy="2286000"/>
           </a:xfrm>
           <a:prstGeom prst="rect">
             <a:avLst/>
@@ -4387,172 +4410,140 @@
       </p:sp>
       <p:sp>
         <p:nvSpPr>
-          <p:cNvPr id="13" name="TextBox 12"/>
-          <p:cNvSpPr txBox="1"/>
-          <p:nvPr/>
-        </p:nvSpPr>
-        <p:spPr>
-          <a:xfrm>
-            <a:off x="6492240" y="1463040"/>
-            <a:ext cx="4937760" cy="411480"/>
-          </a:xfrm>
-          <a:prstGeom prst="rect">
-            <a:avLst/>
-          </a:prstGeom>
-          <a:noFill/>
-        </p:spPr>
-        <p:txBody>
-          <a:bodyPr wrap="square">
-            <a:spAutoFit/>
-          </a:bodyPr>
-          <a:lstStyle/>
-          <a:p>
-            <a:pPr algn="l">
-              <a:spcAft>
-                <a:spcPts val="300"/>
-              </a:spcAft>
-            </a:pPr>
-            <a:r>
-              <a:rPr sz="1600" b="1">
-                <a:solidFill>
-                  <a:srgbClr val="FFFFFF"/>
-                </a:solidFill>
-                <a:latin typeface="Calibri"/>
-              </a:rPr>
-              <a:t>P2 · Espacio de representación</a:t>
-            </a:r>
-          </a:p>
-        </p:txBody>
-      </p:sp>
-      <p:sp>
-        <p:nvSpPr>
           <p:cNvPr id="14" name="TextBox 13"/>
           <p:cNvSpPr txBox="1"/>
           <p:nvPr/>
         </p:nvSpPr>
         <p:spPr>
           <a:xfrm>
-            <a:off x="6492240" y="2377440"/>
-            <a:ext cx="4937760" cy="2011680"/>
-          </a:xfrm>
-          <a:prstGeom prst="rect">
-            <a:avLst/>
-          </a:prstGeom>
-          <a:noFill/>
-        </p:spPr>
-        <p:txBody>
-          <a:bodyPr wrap="square">
-            <a:spAutoFit/>
-          </a:bodyPr>
-          <a:lstStyle/>
-          <a:p>
-            <a:pPr algn="l">
-              <a:spcAft>
-                <a:spcPts val="300"/>
-              </a:spcAft>
-            </a:pPr>
-            <a:r>
-              <a:rPr sz="2000" b="1">
+            <a:off x="777240" y="4023360"/>
+            <a:ext cx="10515600" cy="274320"/>
+          </a:xfrm>
+          <a:prstGeom prst="rect">
+            <a:avLst/>
+          </a:prstGeom>
+          <a:noFill/>
+        </p:spPr>
+        <p:txBody>
+          <a:bodyPr wrap="square">
+            <a:spAutoFit/>
+          </a:bodyPr>
+          <a:lstStyle/>
+          <a:p>
+            <a:pPr algn="l">
+              <a:spcAft>
+                <a:spcPts val="300"/>
+              </a:spcAft>
+            </a:pPr>
+            <a:r>
+              <a:rPr sz="1200" b="1">
+                <a:solidFill>
+                  <a:srgbClr val="0E1216"/>
+                </a:solidFill>
+                <a:latin typeface="Calibri"/>
+              </a:rPr>
+              <a:t>P2  ·  MAPEOS CUÁNTICO-COMPATIBLES</a:t>
+            </a:r>
+          </a:p>
+        </p:txBody>
+      </p:sp>
+      <p:sp>
+        <p:nvSpPr>
+          <p:cNvPr id="15" name="TextBox 14"/>
+          <p:cNvSpPr txBox="1"/>
+          <p:nvPr/>
+        </p:nvSpPr>
+        <p:spPr>
+          <a:xfrm>
+            <a:off x="777240" y="4389120"/>
+            <a:ext cx="10515600" cy="914400"/>
+          </a:xfrm>
+          <a:prstGeom prst="rect">
+            <a:avLst/>
+          </a:prstGeom>
+          <a:noFill/>
+        </p:spPr>
+        <p:txBody>
+          <a:bodyPr wrap="square">
+            <a:spAutoFit/>
+          </a:bodyPr>
+          <a:lstStyle/>
+          <a:p>
+            <a:pPr algn="l">
+              <a:spcAft>
+                <a:spcPts val="300"/>
+              </a:spcAft>
+            </a:pPr>
+            <a:r>
+              <a:rPr sz="1500" b="1">
                 <a:solidFill>
                   <a:srgbClr val="14181C"/>
                 </a:solidFill>
                 <a:latin typeface="Calibri"/>
               </a:rPr>
-              <a:t>Si el dataset no es</a:t>
-            </a:r>
-          </a:p>
-          <a:p>
-            <a:pPr algn="l">
-              <a:spcAft>
-                <a:spcPts val="300"/>
-              </a:spcAft>
-            </a:pPr>
-            <a:r>
-              <a:rPr sz="2000" b="1">
+              <a:t>Si un dataset no tiene estructura cuántica nativa, ¿puede transformarse a un</a:t>
+            </a:r>
+          </a:p>
+          <a:p>
+            <a:pPr algn="l">
+              <a:spcAft>
+                <a:spcPts val="300"/>
+              </a:spcAft>
+            </a:pPr>
+            <a:r>
+              <a:rPr sz="1500" b="1">
                 <a:solidFill>
                   <a:srgbClr val="14181C"/>
                 </a:solidFill>
                 <a:latin typeface="Calibri"/>
               </a:rPr>
-              <a:t>cuántico-compatible,</a:t>
-            </a:r>
-          </a:p>
-          <a:p>
-            <a:pPr algn="l">
-              <a:spcAft>
-                <a:spcPts val="300"/>
-              </a:spcAft>
-            </a:pPr>
-            <a:r>
-              <a:rPr sz="2000" b="1">
-                <a:solidFill>
-                  <a:srgbClr val="14181C"/>
-                </a:solidFill>
-                <a:latin typeface="Calibri"/>
-              </a:rPr>
-              <a:t>¿se puede remapear?</a:t>
-            </a:r>
-          </a:p>
-        </p:txBody>
-      </p:sp>
-      <p:sp>
-        <p:nvSpPr>
-          <p:cNvPr id="15" name="TextBox 14"/>
-          <p:cNvSpPr txBox="1"/>
-          <p:nvPr/>
-        </p:nvSpPr>
-        <p:spPr>
-          <a:xfrm>
-            <a:off x="6492240" y="4846320"/>
-            <a:ext cx="4937760" cy="914400"/>
-          </a:xfrm>
-          <a:prstGeom prst="rect">
-            <a:avLst/>
-          </a:prstGeom>
-          <a:noFill/>
-        </p:spPr>
-        <p:txBody>
-          <a:bodyPr wrap="square">
-            <a:spAutoFit/>
-          </a:bodyPr>
-          <a:lstStyle/>
-          <a:p>
-            <a:pPr algn="l">
-              <a:spcAft>
-                <a:spcPts val="300"/>
-              </a:spcAft>
-            </a:pPr>
-            <a:r>
-              <a:rPr sz="1400" b="0">
+              <a:t>espacio de representación donde la tenga, sin alterar la información discriminativa?</a:t>
+            </a:r>
+          </a:p>
+        </p:txBody>
+      </p:sp>
+      <p:sp>
+        <p:nvSpPr>
+          <p:cNvPr id="16" name="TextBox 15"/>
+          <p:cNvSpPr txBox="1"/>
+          <p:nvPr/>
+        </p:nvSpPr>
+        <p:spPr>
+          <a:xfrm>
+            <a:off x="777240" y="5440680"/>
+            <a:ext cx="10515600" cy="457200"/>
+          </a:xfrm>
+          <a:prstGeom prst="rect">
+            <a:avLst/>
+          </a:prstGeom>
+          <a:noFill/>
+        </p:spPr>
+        <p:txBody>
+          <a:bodyPr wrap="square">
+            <a:spAutoFit/>
+          </a:bodyPr>
+          <a:lstStyle/>
+          <a:p>
+            <a:pPr algn="l">
+              <a:spcAft>
+                <a:spcPts val="300"/>
+              </a:spcAft>
+            </a:pPr>
+            <a:r>
+              <a:rPr sz="1200" b="0">
                 <a:solidFill>
                   <a:srgbClr val="6B737A"/>
                 </a:solidFill>
                 <a:latin typeface="Calibri"/>
               </a:rPr>
-              <a:t>Propuesta: framework QCR</a:t>
-            </a:r>
-          </a:p>
-          <a:p>
-            <a:pPr algn="l">
-              <a:spcAft>
-                <a:spcPts val="300"/>
-              </a:spcAft>
-            </a:pPr>
-            <a:r>
-              <a:rPr sz="1400" b="0">
-                <a:solidFill>
-                  <a:srgbClr val="6B737A"/>
-                </a:solidFill>
-                <a:latin typeface="Calibri"/>
-              </a:rPr>
-              <a:t>planteado formalmente (conjetura abierta)</a:t>
-            </a:r>
-          </a:p>
-        </p:txBody>
-      </p:sp>
-      <p:sp>
-        <p:nvSpPr>
-          <p:cNvPr id="16" name="TextBox 15"/>
+              <a:t>Respuesta propuesta: framework QCR + conjetura del espacio Z (ψ polinómica) — planteada formalmente, abierta</a:t>
+            </a:r>
+          </a:p>
+        </p:txBody>
+      </p:sp>
+      <p:sp>
+        <p:nvSpPr>
+          <p:cNvPr id="17" name="TextBox 16"/>
           <p:cNvSpPr txBox="1"/>
           <p:nvPr/>
         </p:nvSpPr>
@@ -4591,7 +4582,7 @@
       </p:sp>
       <p:sp>
         <p:nvSpPr>
-          <p:cNvPr id="17" name="TextBox 16"/>
+          <p:cNvPr id="18" name="TextBox 17"/>
           <p:cNvSpPr txBox="1"/>
           <p:nvPr/>
         </p:nvSpPr>
@@ -6546,7 +6537,7 @@
                 </a:solidFill>
                 <a:latin typeface="Calibri"/>
               </a:rPr>
-              <a:t>RESULTADOS · P1</a:t>
+              <a:t>RESPUESTA A P1</a:t>
             </a:r>
           </a:p>
         </p:txBody>
@@ -6585,7 +6576,7 @@
                 </a:solidFill>
                 <a:latin typeface="Calibri"/>
               </a:rPr>
-              <a:t>Score de cuanticidad Q(D)</a:t>
+              <a:t>Score Q(D): indicador a priori de ventaja</a:t>
             </a:r>
           </a:p>
         </p:txBody>
@@ -10007,7 +9998,7 @@
                 </a:solidFill>
                 <a:latin typeface="Calibri"/>
               </a:rPr>
-              <a:t>Pregunta y objetivos</a:t>
+              <a:t>Problema central y objetivos</a:t>
             </a:r>
           </a:p>
         </p:txBody>
@@ -10130,7 +10121,7 @@
                 </a:solidFill>
                 <a:latin typeface="Calibri"/>
               </a:rPr>
-              <a:t>Estado del arte y posicionamiento</a:t>
+              <a:t>Estado del arte</a:t>
             </a:r>
           </a:p>
         </p:txBody>
@@ -10376,7 +10367,7 @@
                 </a:solidFill>
                 <a:latin typeface="Calibri"/>
               </a:rPr>
-              <a:t>Problemas de investigación (Q(D), QCR)</a:t>
+              <a:t>Preguntas originales (tras la evidencia)</a:t>
             </a:r>
           </a:p>
         </p:txBody>
@@ -12010,7 +12001,7 @@
                 </a:solidFill>
                 <a:latin typeface="Calibri"/>
               </a:rPr>
-              <a:t>FORMULACIÓN DE LA TESIS</a:t>
+              <a:t>PLANTEAMIENTO DEL PROBLEMA</a:t>
             </a:r>
           </a:p>
         </p:txBody>
@@ -12049,7 +12040,7 @@
                 </a:solidFill>
                 <a:latin typeface="Calibri"/>
               </a:rPr>
-              <a:t>Pregunta e hipótesis</a:t>
+              <a:t>Problema central del TFM</a:t>
             </a:r>
           </a:p>
         </p:txBody>
@@ -12105,8 +12096,8 @@
         </p:nvSpPr>
         <p:spPr>
           <a:xfrm>
-            <a:off x="502920" y="1371600"/>
-            <a:ext cx="11155680" cy="2377440"/>
+            <a:off x="502920" y="1325880"/>
+            <a:ext cx="11155680" cy="2286000"/>
           </a:xfrm>
           <a:prstGeom prst="rect">
             <a:avLst/>
@@ -12150,8 +12141,8 @@
         </p:nvSpPr>
         <p:spPr>
           <a:xfrm>
-            <a:off x="502920" y="1371600"/>
-            <a:ext cx="91440" cy="2377440"/>
+            <a:off x="502920" y="1325880"/>
+            <a:ext cx="91440" cy="2286000"/>
           </a:xfrm>
           <a:prstGeom prst="rect">
             <a:avLst/>
@@ -12193,7 +12184,7 @@
         </p:nvSpPr>
         <p:spPr>
           <a:xfrm>
-            <a:off x="914400" y="1691640"/>
+            <a:off x="914400" y="1554480"/>
             <a:ext cx="10241280" cy="1828800"/>
           </a:xfrm>
           <a:prstGeom prst="rect">
@@ -12213,7 +12204,7 @@
               </a:spcAft>
             </a:pPr>
             <a:r>
-              <a:rPr sz="2000" b="1">
+              <a:rPr sz="1800" b="1">
                 <a:solidFill>
                   <a:srgbClr val="14181C"/>
                 </a:solidFill>
@@ -12229,43 +12220,82 @@
               </a:spcAft>
             </a:pPr>
             <a:r>
-              <a:rPr sz="2000" b="1">
+              <a:rPr sz="1800" b="1">
                 <a:solidFill>
                   <a:srgbClr val="14181C"/>
                 </a:solidFill>
                 <a:latin typeface="Calibri"/>
               </a:rPr>
-              <a:t>los algoritmos cuánticos NISQ ofrecen una ventaja real y medible</a:t>
-            </a:r>
-          </a:p>
-          <a:p>
-            <a:pPr algn="l">
-              <a:spcAft>
-                <a:spcPts val="300"/>
-              </a:spcAft>
-            </a:pPr>
-            <a:r>
-              <a:rPr sz="2000" b="1">
+              <a:t>los algoritmos cuánticos disponibles en la era NISQ ofrecen una</a:t>
+            </a:r>
+          </a:p>
+          <a:p>
+            <a:pPr algn="l">
+              <a:spcAft>
+                <a:spcPts val="300"/>
+              </a:spcAft>
+            </a:pPr>
+            <a:r>
+              <a:rPr sz="1800" b="1">
                 <a:solidFill>
                   <a:srgbClr val="14181C"/>
                 </a:solidFill>
                 <a:latin typeface="Calibri"/>
               </a:rPr>
-              <a:t>frente a los algoritmos clásicos?</a:t>
-            </a:r>
-          </a:p>
-        </p:txBody>
-      </p:sp>
-      <p:sp>
-        <p:nvSpPr>
-          <p:cNvPr id="9" name="Rectangle 8"/>
+              <a:t>ventaja real y medible frente a los algoritmos clásicos?</a:t>
+            </a:r>
+          </a:p>
+        </p:txBody>
+      </p:sp>
+      <p:sp>
+        <p:nvSpPr>
+          <p:cNvPr id="9" name="TextBox 8"/>
+          <p:cNvSpPr txBox="1"/>
+          <p:nvPr/>
+        </p:nvSpPr>
+        <p:spPr>
+          <a:xfrm>
+            <a:off x="640080" y="3840480"/>
+            <a:ext cx="11155680" cy="320040"/>
+          </a:xfrm>
+          <a:prstGeom prst="rect">
+            <a:avLst/>
+          </a:prstGeom>
+          <a:noFill/>
+        </p:spPr>
+        <p:txBody>
+          <a:bodyPr wrap="square">
+            <a:spAutoFit/>
+          </a:bodyPr>
+          <a:lstStyle/>
+          <a:p>
+            <a:pPr algn="l">
+              <a:spcAft>
+                <a:spcPts val="300"/>
+              </a:spcAft>
+            </a:pPr>
+            <a:r>
+              <a:rPr sz="1200" b="1">
+                <a:solidFill>
+                  <a:srgbClr val="0B6E6A"/>
+                </a:solidFill>
+                <a:latin typeface="Calibri"/>
+              </a:rPr>
+              <a:t>CÓMO SE ATACA  ·  estudio comparativo empírico</a:t>
+            </a:r>
+          </a:p>
+        </p:txBody>
+      </p:sp>
+      <p:sp>
+        <p:nvSpPr>
+          <p:cNvPr id="10" name="Rectangle 9"/>
           <p:cNvSpPr/>
           <p:nvPr/>
         </p:nvSpPr>
         <p:spPr>
           <a:xfrm>
-            <a:off x="502920" y="4023360"/>
-            <a:ext cx="11155680" cy="2103120"/>
+            <a:off x="502920" y="4251960"/>
+            <a:ext cx="2743200" cy="1737360"/>
           </a:xfrm>
           <a:prstGeom prst="rect">
             <a:avLst/>
@@ -12303,117 +12333,518 @@
       </p:sp>
       <p:sp>
         <p:nvSpPr>
-          <p:cNvPr id="10" name="TextBox 9"/>
-          <p:cNvSpPr txBox="1"/>
-          <p:nvPr/>
-        </p:nvSpPr>
-        <p:spPr>
-          <a:xfrm>
-            <a:off x="777240" y="4206240"/>
-            <a:ext cx="10515600" cy="365760"/>
-          </a:xfrm>
-          <a:prstGeom prst="rect">
-            <a:avLst/>
-          </a:prstGeom>
-          <a:noFill/>
-        </p:spPr>
-        <p:txBody>
-          <a:bodyPr wrap="square">
-            <a:spAutoFit/>
-          </a:bodyPr>
-          <a:lstStyle/>
-          <a:p>
-            <a:pPr algn="l">
-              <a:spcAft>
-                <a:spcPts val="300"/>
-              </a:spcAft>
-            </a:pPr>
-            <a:r>
-              <a:rPr sz="1200" b="1">
+          <p:cNvPr id="11" name="TextBox 10"/>
+          <p:cNvSpPr txBox="1"/>
+          <p:nvPr/>
+        </p:nvSpPr>
+        <p:spPr>
+          <a:xfrm>
+            <a:off x="685800" y="4434840"/>
+            <a:ext cx="2377440" cy="365760"/>
+          </a:xfrm>
+          <a:prstGeom prst="rect">
+            <a:avLst/>
+          </a:prstGeom>
+          <a:noFill/>
+        </p:spPr>
+        <p:txBody>
+          <a:bodyPr wrap="square">
+            <a:spAutoFit/>
+          </a:bodyPr>
+          <a:lstStyle/>
+          <a:p>
+            <a:pPr algn="l">
+              <a:spcAft>
+                <a:spcPts val="300"/>
+              </a:spcAft>
+            </a:pPr>
+            <a:r>
+              <a:rPr sz="1400" b="1">
                 <a:solidFill>
                   <a:srgbClr val="0B6E6A"/>
                 </a:solidFill>
                 <a:latin typeface="Calibri"/>
               </a:rPr>
-              <a:t>HIPÓTESIS OPERATIVA</a:t>
-            </a:r>
-          </a:p>
-        </p:txBody>
-      </p:sp>
-      <p:sp>
-        <p:nvSpPr>
-          <p:cNvPr id="11" name="TextBox 10"/>
-          <p:cNvSpPr txBox="1"/>
-          <p:nvPr/>
-        </p:nvSpPr>
-        <p:spPr>
-          <a:xfrm>
-            <a:off x="777240" y="4663440"/>
-            <a:ext cx="10515600" cy="1188720"/>
-          </a:xfrm>
-          <a:prstGeom prst="rect">
-            <a:avLst/>
-          </a:prstGeom>
-          <a:noFill/>
-        </p:spPr>
-        <p:txBody>
-          <a:bodyPr wrap="square">
-            <a:spAutoFit/>
-          </a:bodyPr>
-          <a:lstStyle/>
-          <a:p>
-            <a:pPr algn="l">
-              <a:spcAft>
-                <a:spcPts val="300"/>
-              </a:spcAft>
-            </a:pPr>
-            <a:r>
-              <a:rPr sz="1600" b="0">
+              <a:t>Clasificación</a:t>
+            </a:r>
+          </a:p>
+        </p:txBody>
+      </p:sp>
+      <p:sp>
+        <p:nvSpPr>
+          <p:cNvPr id="12" name="TextBox 11"/>
+          <p:cNvSpPr txBox="1"/>
+          <p:nvPr/>
+        </p:nvSpPr>
+        <p:spPr>
+          <a:xfrm>
+            <a:off x="685800" y="4892040"/>
+            <a:ext cx="2377440" cy="822960"/>
+          </a:xfrm>
+          <a:prstGeom prst="rect">
+            <a:avLst/>
+          </a:prstGeom>
+          <a:noFill/>
+        </p:spPr>
+        <p:txBody>
+          <a:bodyPr wrap="square">
+            <a:spAutoFit/>
+          </a:bodyPr>
+          <a:lstStyle/>
+          <a:p>
+            <a:pPr algn="l">
+              <a:spcAft>
+                <a:spcPts val="300"/>
+              </a:spcAft>
+            </a:pPr>
+            <a:r>
+              <a:rPr sz="1300" b="0">
                 <a:solidFill>
                   <a:srgbClr val="14181C"/>
                 </a:solidFill>
                 <a:latin typeface="Calibri"/>
               </a:rPr>
-              <a:t>La ventaja es real pero condicionada:</a:t>
-            </a:r>
-          </a:p>
-          <a:p>
-            <a:pPr algn="l">
-              <a:spcAft>
-                <a:spcPts val="300"/>
-              </a:spcAft>
-            </a:pPr>
-            <a:r>
-              <a:rPr sz="1600" b="0">
+              <a:t>Kernels QSVM</a:t>
+            </a:r>
+          </a:p>
+          <a:p>
+            <a:pPr algn="l">
+              <a:spcAft>
+                <a:spcPts val="300"/>
+              </a:spcAft>
+            </a:pPr>
+            <a:r>
+              <a:rPr sz="1300" b="0">
                 <a:solidFill>
                   <a:srgbClr val="14181C"/>
                 </a:solidFill>
                 <a:latin typeface="Calibri"/>
               </a:rPr>
-              <a:t>(1) alineación feature map ↔ generador de datos, o</a:t>
-            </a:r>
-          </a:p>
-          <a:p>
-            <a:pPr algn="l">
-              <a:spcAft>
-                <a:spcPts val="300"/>
-              </a:spcAft>
-            </a:pPr>
-            <a:r>
-              <a:rPr sz="1600" b="0">
+              <a:t>vs SVM / boosting</a:t>
+            </a:r>
+          </a:p>
+        </p:txBody>
+      </p:sp>
+      <p:sp>
+        <p:nvSpPr>
+          <p:cNvPr id="13" name="Rectangle 12"/>
+          <p:cNvSpPr/>
+          <p:nvPr/>
+        </p:nvSpPr>
+        <p:spPr>
+          <a:xfrm>
+            <a:off x="3383280" y="4251960"/>
+            <a:ext cx="2743200" cy="1737360"/>
+          </a:xfrm>
+          <a:prstGeom prst="rect">
+            <a:avLst/>
+          </a:prstGeom>
+          <a:solidFill>
+            <a:srgbClr val="FFFFFF"/>
+          </a:solidFill>
+          <a:ln w="12700">
+            <a:solidFill>
+              <a:srgbClr val="E6E1D8"/>
+            </a:solidFill>
+          </a:ln>
+        </p:spPr>
+        <p:style>
+          <a:lnRef idx="1">
+            <a:schemeClr val="accent1"/>
+          </a:lnRef>
+          <a:fillRef idx="3">
+            <a:schemeClr val="accent1"/>
+          </a:fillRef>
+          <a:effectRef idx="2">
+            <a:schemeClr val="accent1"/>
+          </a:effectRef>
+          <a:fontRef idx="minor">
+            <a:schemeClr val="lt1"/>
+          </a:fontRef>
+        </p:style>
+        <p:txBody>
+          <a:bodyPr rtlCol="0" anchor="ctr"/>
+          <a:lstStyle/>
+          <a:p>
+            <a:pPr algn="ctr"/>
+          </a:p>
+        </p:txBody>
+      </p:sp>
+      <p:sp>
+        <p:nvSpPr>
+          <p:cNvPr id="14" name="TextBox 13"/>
+          <p:cNvSpPr txBox="1"/>
+          <p:nvPr/>
+        </p:nvSpPr>
+        <p:spPr>
+          <a:xfrm>
+            <a:off x="3566160" y="4434840"/>
+            <a:ext cx="2377440" cy="365760"/>
+          </a:xfrm>
+          <a:prstGeom prst="rect">
+            <a:avLst/>
+          </a:prstGeom>
+          <a:noFill/>
+        </p:spPr>
+        <p:txBody>
+          <a:bodyPr wrap="square">
+            <a:spAutoFit/>
+          </a:bodyPr>
+          <a:lstStyle/>
+          <a:p>
+            <a:pPr algn="l">
+              <a:spcAft>
+                <a:spcPts val="300"/>
+              </a:spcAft>
+            </a:pPr>
+            <a:r>
+              <a:rPr sz="1400" b="1">
+                <a:solidFill>
+                  <a:srgbClr val="0B6E6A"/>
+                </a:solidFill>
+                <a:latin typeface="Calibri"/>
+              </a:rPr>
+              <a:t>Regresión</a:t>
+            </a:r>
+          </a:p>
+        </p:txBody>
+      </p:sp>
+      <p:sp>
+        <p:nvSpPr>
+          <p:cNvPr id="15" name="TextBox 14"/>
+          <p:cNvSpPr txBox="1"/>
+          <p:nvPr/>
+        </p:nvSpPr>
+        <p:spPr>
+          <a:xfrm>
+            <a:off x="3566160" y="4892040"/>
+            <a:ext cx="2377440" cy="822960"/>
+          </a:xfrm>
+          <a:prstGeom prst="rect">
+            <a:avLst/>
+          </a:prstGeom>
+          <a:noFill/>
+        </p:spPr>
+        <p:txBody>
+          <a:bodyPr wrap="square">
+            <a:spAutoFit/>
+          </a:bodyPr>
+          <a:lstStyle/>
+          <a:p>
+            <a:pPr algn="l">
+              <a:spcAft>
+                <a:spcPts val="300"/>
+              </a:spcAft>
+            </a:pPr>
+            <a:r>
+              <a:rPr sz="1300" b="0">
                 <a:solidFill>
                   <a:srgbClr val="14181C"/>
                 </a:solidFill>
                 <a:latin typeface="Calibri"/>
               </a:rPr>
-              <a:t>(2) problema QUBO con diseño híbrido cuántico–clásico a escala viable.</a:t>
-            </a:r>
-          </a:p>
-        </p:txBody>
-      </p:sp>
-      <p:sp>
-        <p:nvSpPr>
-          <p:cNvPr id="12" name="TextBox 11"/>
+              <a:t>QK-SVR</a:t>
+            </a:r>
+          </a:p>
+          <a:p>
+            <a:pPr algn="l">
+              <a:spcAft>
+                <a:spcPts val="300"/>
+              </a:spcAft>
+            </a:pPr>
+            <a:r>
+              <a:rPr sz="1300" b="0">
+                <a:solidFill>
+                  <a:srgbClr val="14181C"/>
+                </a:solidFill>
+                <a:latin typeface="Calibri"/>
+              </a:rPr>
+              <a:t>vs Ridge / árboles</a:t>
+            </a:r>
+          </a:p>
+        </p:txBody>
+      </p:sp>
+      <p:sp>
+        <p:nvSpPr>
+          <p:cNvPr id="16" name="Rectangle 15"/>
+          <p:cNvSpPr/>
+          <p:nvPr/>
+        </p:nvSpPr>
+        <p:spPr>
+          <a:xfrm>
+            <a:off x="6263640" y="4251960"/>
+            <a:ext cx="2743200" cy="1737360"/>
+          </a:xfrm>
+          <a:prstGeom prst="rect">
+            <a:avLst/>
+          </a:prstGeom>
+          <a:solidFill>
+            <a:srgbClr val="FFFFFF"/>
+          </a:solidFill>
+          <a:ln w="12700">
+            <a:solidFill>
+              <a:srgbClr val="E6E1D8"/>
+            </a:solidFill>
+          </a:ln>
+        </p:spPr>
+        <p:style>
+          <a:lnRef idx="1">
+            <a:schemeClr val="accent1"/>
+          </a:lnRef>
+          <a:fillRef idx="3">
+            <a:schemeClr val="accent1"/>
+          </a:fillRef>
+          <a:effectRef idx="2">
+            <a:schemeClr val="accent1"/>
+          </a:effectRef>
+          <a:fontRef idx="minor">
+            <a:schemeClr val="lt1"/>
+          </a:fontRef>
+        </p:style>
+        <p:txBody>
+          <a:bodyPr rtlCol="0" anchor="ctr"/>
+          <a:lstStyle/>
+          <a:p>
+            <a:pPr algn="ctr"/>
+          </a:p>
+        </p:txBody>
+      </p:sp>
+      <p:sp>
+        <p:nvSpPr>
+          <p:cNvPr id="17" name="TextBox 16"/>
+          <p:cNvSpPr txBox="1"/>
+          <p:nvPr/>
+        </p:nvSpPr>
+        <p:spPr>
+          <a:xfrm>
+            <a:off x="6446520" y="4434840"/>
+            <a:ext cx="2377440" cy="365760"/>
+          </a:xfrm>
+          <a:prstGeom prst="rect">
+            <a:avLst/>
+          </a:prstGeom>
+          <a:noFill/>
+        </p:spPr>
+        <p:txBody>
+          <a:bodyPr wrap="square">
+            <a:spAutoFit/>
+          </a:bodyPr>
+          <a:lstStyle/>
+          <a:p>
+            <a:pPr algn="l">
+              <a:spcAft>
+                <a:spcPts val="300"/>
+              </a:spcAft>
+            </a:pPr>
+            <a:r>
+              <a:rPr sz="1400" b="1">
+                <a:solidFill>
+                  <a:srgbClr val="0B6E6A"/>
+                </a:solidFill>
+                <a:latin typeface="Calibri"/>
+              </a:rPr>
+              <a:t>Optimización</a:t>
+            </a:r>
+          </a:p>
+        </p:txBody>
+      </p:sp>
+      <p:sp>
+        <p:nvSpPr>
+          <p:cNvPr id="18" name="TextBox 17"/>
+          <p:cNvSpPr txBox="1"/>
+          <p:nvPr/>
+        </p:nvSpPr>
+        <p:spPr>
+          <a:xfrm>
+            <a:off x="6446520" y="4892040"/>
+            <a:ext cx="2377440" cy="822960"/>
+          </a:xfrm>
+          <a:prstGeom prst="rect">
+            <a:avLst/>
+          </a:prstGeom>
+          <a:noFill/>
+        </p:spPr>
+        <p:txBody>
+          <a:bodyPr wrap="square">
+            <a:spAutoFit/>
+          </a:bodyPr>
+          <a:lstStyle/>
+          <a:p>
+            <a:pPr algn="l">
+              <a:spcAft>
+                <a:spcPts val="300"/>
+              </a:spcAft>
+            </a:pPr>
+            <a:r>
+              <a:rPr sz="1300" b="0">
+                <a:solidFill>
+                  <a:srgbClr val="14181C"/>
+                </a:solidFill>
+                <a:latin typeface="Calibri"/>
+              </a:rPr>
+              <a:t>QAOA / VQE</a:t>
+            </a:r>
+          </a:p>
+          <a:p>
+            <a:pPr algn="l">
+              <a:spcAft>
+                <a:spcPts val="300"/>
+              </a:spcAft>
+            </a:pPr>
+            <a:r>
+              <a:rPr sz="1300" b="0">
+                <a:solidFill>
+                  <a:srgbClr val="14181C"/>
+                </a:solidFill>
+                <a:latin typeface="Calibri"/>
+              </a:rPr>
+              <a:t>vs greedy / ILP</a:t>
+            </a:r>
+          </a:p>
+        </p:txBody>
+      </p:sp>
+      <p:sp>
+        <p:nvSpPr>
+          <p:cNvPr id="19" name="Rectangle 18"/>
+          <p:cNvSpPr/>
+          <p:nvPr/>
+        </p:nvSpPr>
+        <p:spPr>
+          <a:xfrm>
+            <a:off x="9144000" y="4251960"/>
+            <a:ext cx="2743200" cy="1737360"/>
+          </a:xfrm>
+          <a:prstGeom prst="rect">
+            <a:avLst/>
+          </a:prstGeom>
+          <a:solidFill>
+            <a:srgbClr val="FFFFFF"/>
+          </a:solidFill>
+          <a:ln w="12700">
+            <a:solidFill>
+              <a:srgbClr val="E6E1D8"/>
+            </a:solidFill>
+          </a:ln>
+        </p:spPr>
+        <p:style>
+          <a:lnRef idx="1">
+            <a:schemeClr val="accent1"/>
+          </a:lnRef>
+          <a:fillRef idx="3">
+            <a:schemeClr val="accent1"/>
+          </a:fillRef>
+          <a:effectRef idx="2">
+            <a:schemeClr val="accent1"/>
+          </a:effectRef>
+          <a:fontRef idx="minor">
+            <a:schemeClr val="lt1"/>
+          </a:fontRef>
+        </p:style>
+        <p:txBody>
+          <a:bodyPr rtlCol="0" anchor="ctr"/>
+          <a:lstStyle/>
+          <a:p>
+            <a:pPr algn="ctr"/>
+          </a:p>
+        </p:txBody>
+      </p:sp>
+      <p:sp>
+        <p:nvSpPr>
+          <p:cNvPr id="20" name="TextBox 19"/>
+          <p:cNvSpPr txBox="1"/>
+          <p:nvPr/>
+        </p:nvSpPr>
+        <p:spPr>
+          <a:xfrm>
+            <a:off x="9326880" y="4434840"/>
+            <a:ext cx="2377440" cy="365760"/>
+          </a:xfrm>
+          <a:prstGeom prst="rect">
+            <a:avLst/>
+          </a:prstGeom>
+          <a:noFill/>
+        </p:spPr>
+        <p:txBody>
+          <a:bodyPr wrap="square">
+            <a:spAutoFit/>
+          </a:bodyPr>
+          <a:lstStyle/>
+          <a:p>
+            <a:pPr algn="l">
+              <a:spcAft>
+                <a:spcPts val="300"/>
+              </a:spcAft>
+            </a:pPr>
+            <a:r>
+              <a:rPr sz="1400" b="1">
+                <a:solidFill>
+                  <a:srgbClr val="0B6E6A"/>
+                </a:solidFill>
+                <a:latin typeface="Calibri"/>
+              </a:rPr>
+              <a:t>Híbrido</a:t>
+            </a:r>
+          </a:p>
+        </p:txBody>
+      </p:sp>
+      <p:sp>
+        <p:nvSpPr>
+          <p:cNvPr id="21" name="TextBox 20"/>
+          <p:cNvSpPr txBox="1"/>
+          <p:nvPr/>
+        </p:nvSpPr>
+        <p:spPr>
+          <a:xfrm>
+            <a:off x="9326880" y="4892040"/>
+            <a:ext cx="2377440" cy="822960"/>
+          </a:xfrm>
+          <a:prstGeom prst="rect">
+            <a:avLst/>
+          </a:prstGeom>
+          <a:noFill/>
+        </p:spPr>
+        <p:txBody>
+          <a:bodyPr wrap="square">
+            <a:spAutoFit/>
+          </a:bodyPr>
+          <a:lstStyle/>
+          <a:p>
+            <a:pPr algn="l">
+              <a:spcAft>
+                <a:spcPts val="300"/>
+              </a:spcAft>
+            </a:pPr>
+            <a:r>
+              <a:rPr sz="1300" b="0">
+                <a:solidFill>
+                  <a:srgbClr val="14181C"/>
+                </a:solidFill>
+                <a:latin typeface="Calibri"/>
+              </a:rPr>
+              <a:t>QAOA–COBYLA</a:t>
+            </a:r>
+          </a:p>
+          <a:p>
+            <a:pPr algn="l">
+              <a:spcAft>
+                <a:spcPts val="300"/>
+              </a:spcAft>
+            </a:pPr>
+            <a:r>
+              <a:rPr sz="1300" b="0">
+                <a:solidFill>
+                  <a:srgbClr val="14181C"/>
+                </a:solidFill>
+                <a:latin typeface="Calibri"/>
+              </a:rPr>
+              <a:t>(MDS, QUBO)</a:t>
+            </a:r>
+          </a:p>
+        </p:txBody>
+      </p:sp>
+      <p:sp>
+        <p:nvSpPr>
+          <p:cNvPr id="22" name="TextBox 21"/>
           <p:cNvSpPr txBox="1"/>
           <p:nvPr/>
         </p:nvSpPr>
@@ -12452,7 +12883,7 @@
       </p:sp>
       <p:sp>
         <p:nvSpPr>
-          <p:cNvPr id="13" name="TextBox 12"/>
+          <p:cNvPr id="23" name="TextBox 22"/>
           <p:cNvSpPr txBox="1"/>
           <p:nvPr/>
         </p:nvSpPr>

</xml_diff>